<commit_message>
Subiendo la ppt terminada
</commit_message>
<xml_diff>
--- a/PROYECTO FINAL/AVANCE PPT/Avance1_ProyectoPW.pptx
+++ b/PROYECTO FINAL/AVANCE PPT/Avance1_ProyectoPW.pptx
@@ -13,8 +13,15 @@
     <p:sldId id="260" r:id="rId7"/>
     <p:sldId id="261" r:id="rId8"/>
     <p:sldId id="264" r:id="rId9"/>
-    <p:sldId id="262" r:id="rId10"/>
-    <p:sldId id="263" r:id="rId11"/>
+    <p:sldId id="266" r:id="rId10"/>
+    <p:sldId id="267" r:id="rId11"/>
+    <p:sldId id="268" r:id="rId12"/>
+    <p:sldId id="269" r:id="rId13"/>
+    <p:sldId id="270" r:id="rId14"/>
+    <p:sldId id="271" r:id="rId15"/>
+    <p:sldId id="272" r:id="rId16"/>
+    <p:sldId id="262" r:id="rId17"/>
+    <p:sldId id="263" r:id="rId18"/>
   </p:sldIdLst>
   <p:sldSz cx="18288000" cy="10287000"/>
   <p:notesSz cx="18288000" cy="10287000"/>
@@ -2283,6 +2290,1128 @@
 </file>
 
 <file path=ppt/slides/slide10.xml><?xml version="1.0" encoding="utf-8"?>
+<p:sld xmlns:a="http://schemas.openxmlformats.org/drawingml/2006/main" xmlns:r="http://schemas.openxmlformats.org/officeDocument/2006/relationships" xmlns:p="http://schemas.openxmlformats.org/presentationml/2006/main">
+  <p:cSld>
+    <p:spTree>
+      <p:nvGrpSpPr>
+        <p:cNvPr id="1" name=""/>
+        <p:cNvGrpSpPr/>
+        <p:nvPr/>
+      </p:nvGrpSpPr>
+      <p:grpSpPr>
+        <a:xfrm>
+          <a:off x="0" y="0"/>
+          <a:ext cx="0" cy="0"/>
+          <a:chOff x="0" y="0"/>
+          <a:chExt cx="0" cy="0"/>
+        </a:xfrm>
+      </p:grpSpPr>
+      <p:pic>
+        <p:nvPicPr>
+          <p:cNvPr id="3" name="Picture 1">
+            <a:extLst>
+              <a:ext uri="{FF2B5EF4-FFF2-40B4-BE49-F238E27FC236}">
+                <a16:creationId xmlns:a16="http://schemas.microsoft.com/office/drawing/2014/main" id="{B6C29272-C4B8-C090-D15E-910FD7204FC6}"/>
+              </a:ext>
+            </a:extLst>
+          </p:cNvPr>
+          <p:cNvPicPr>
+            <a:picLocks noChangeAspect="1"/>
+          </p:cNvPicPr>
+          <p:nvPr/>
+        </p:nvPicPr>
+        <p:blipFill>
+          <a:blip r:embed="rId2">
+            <a:extLst>
+              <a:ext uri="{28A0092B-C50C-407E-A947-70E740481C1C}">
+                <a14:useLocalDpi xmlns:a14="http://schemas.microsoft.com/office/drawing/2010/main" val="0"/>
+              </a:ext>
+            </a:extLst>
+          </a:blip>
+          <a:stretch>
+            <a:fillRect/>
+          </a:stretch>
+        </p:blipFill>
+        <p:spPr>
+          <a:xfrm>
+            <a:off x="2362200" y="2701607"/>
+            <a:ext cx="13821476" cy="5261293"/>
+          </a:xfrm>
+          <a:prstGeom prst="rect">
+            <a:avLst/>
+          </a:prstGeom>
+        </p:spPr>
+      </p:pic>
+      <p:sp>
+        <p:nvSpPr>
+          <p:cNvPr id="5" name="CuadroTexto 4">
+            <a:extLst>
+              <a:ext uri="{FF2B5EF4-FFF2-40B4-BE49-F238E27FC236}">
+                <a16:creationId xmlns:a16="http://schemas.microsoft.com/office/drawing/2014/main" id="{77F4248C-2A76-99F7-6245-F4DF5C2ACF07}"/>
+              </a:ext>
+            </a:extLst>
+          </p:cNvPr>
+          <p:cNvSpPr txBox="1"/>
+          <p:nvPr/>
+        </p:nvSpPr>
+        <p:spPr>
+          <a:xfrm>
+            <a:off x="4343400" y="1866900"/>
+            <a:ext cx="9144000" cy="561629"/>
+          </a:xfrm>
+          <a:prstGeom prst="rect">
+            <a:avLst/>
+          </a:prstGeom>
+          <a:noFill/>
+        </p:spPr>
+        <p:txBody>
+          <a:bodyPr wrap="square">
+            <a:spAutoFit/>
+          </a:bodyPr>
+          <a:lstStyle/>
+          <a:p>
+            <a:pPr indent="450215" algn="just">
+              <a:lnSpc>
+                <a:spcPct val="200000"/>
+              </a:lnSpc>
+              <a:spcAft>
+                <a:spcPts val="800"/>
+              </a:spcAft>
+            </a:pPr>
+            <a:r>
+              <a:rPr lang="es-PE" sz="1800" b="1" dirty="0">
+                <a:latin typeface="Times New Roman" panose="02020603050405020304" pitchFamily="18" charset="0"/>
+                <a:cs typeface="Times New Roman" panose="02020603050405020304" pitchFamily="18" charset="0"/>
+              </a:rPr>
+              <a:t>Flujo de Navegación Coherente (</a:t>
+            </a:r>
+            <a:r>
+              <a:rPr lang="es-PE" sz="1800" b="1" dirty="0" err="1">
+                <a:latin typeface="Times New Roman" panose="02020603050405020304" pitchFamily="18" charset="0"/>
+                <a:cs typeface="Times New Roman" panose="02020603050405020304" pitchFamily="18" charset="0"/>
+              </a:rPr>
+              <a:t>User</a:t>
+            </a:r>
+            <a:r>
+              <a:rPr lang="es-PE" sz="1800" b="1" dirty="0">
+                <a:latin typeface="Times New Roman" panose="02020603050405020304" pitchFamily="18" charset="0"/>
+                <a:cs typeface="Times New Roman" panose="02020603050405020304" pitchFamily="18" charset="0"/>
+              </a:rPr>
+              <a:t> Flow)</a:t>
+            </a:r>
+            <a:r>
+              <a:rPr lang="es-PE" sz="1800" b="1" kern="100" dirty="0">
+                <a:effectLst/>
+                <a:latin typeface="Times New Roman" panose="02020603050405020304" pitchFamily="18" charset="0"/>
+                <a:ea typeface="Calibri" panose="020F0502020204030204" pitchFamily="34" charset="0"/>
+                <a:cs typeface="Times New Roman" panose="02020603050405020304" pitchFamily="18" charset="0"/>
+              </a:rPr>
+              <a:t>:</a:t>
+            </a:r>
+          </a:p>
+        </p:txBody>
+      </p:sp>
+    </p:spTree>
+    <p:extLst>
+      <p:ext uri="{BB962C8B-B14F-4D97-AF65-F5344CB8AC3E}">
+        <p14:creationId xmlns:p14="http://schemas.microsoft.com/office/powerpoint/2010/main" val="3173398295"/>
+      </p:ext>
+    </p:extLst>
+  </p:cSld>
+  <p:clrMapOvr>
+    <a:masterClrMapping/>
+  </p:clrMapOvr>
+</p:sld>
+</file>
+
+<file path=ppt/slides/slide11.xml><?xml version="1.0" encoding="utf-8"?>
+<p:sld xmlns:a="http://schemas.openxmlformats.org/drawingml/2006/main" xmlns:r="http://schemas.openxmlformats.org/officeDocument/2006/relationships" xmlns:p="http://schemas.openxmlformats.org/presentationml/2006/main">
+  <p:cSld>
+    <p:spTree>
+      <p:nvGrpSpPr>
+        <p:cNvPr id="1" name=""/>
+        <p:cNvGrpSpPr/>
+        <p:nvPr/>
+      </p:nvGrpSpPr>
+      <p:grpSpPr>
+        <a:xfrm>
+          <a:off x="0" y="0"/>
+          <a:ext cx="0" cy="0"/>
+          <a:chOff x="0" y="0"/>
+          <a:chExt cx="0" cy="0"/>
+        </a:xfrm>
+      </p:grpSpPr>
+      <p:pic>
+        <p:nvPicPr>
+          <p:cNvPr id="3" name="Picture 1">
+            <a:extLst>
+              <a:ext uri="{FF2B5EF4-FFF2-40B4-BE49-F238E27FC236}">
+                <a16:creationId xmlns:a16="http://schemas.microsoft.com/office/drawing/2014/main" id="{E4E8CAEA-5A02-0D5E-C9E9-C3639D95332C}"/>
+              </a:ext>
+            </a:extLst>
+          </p:cNvPr>
+          <p:cNvPicPr>
+            <a:picLocks noChangeAspect="1"/>
+          </p:cNvPicPr>
+          <p:nvPr/>
+        </p:nvPicPr>
+        <p:blipFill rotWithShape="1">
+          <a:blip r:embed="rId2">
+            <a:extLst>
+              <a:ext uri="{28A0092B-C50C-407E-A947-70E740481C1C}">
+                <a14:useLocalDpi xmlns:a14="http://schemas.microsoft.com/office/drawing/2010/main" val="0"/>
+              </a:ext>
+            </a:extLst>
+          </a:blip>
+          <a:srcRect l="2888"/>
+          <a:stretch>
+            <a:fillRect/>
+          </a:stretch>
+        </p:blipFill>
+        <p:spPr bwMode="auto">
+          <a:xfrm>
+            <a:off x="2895600" y="711349"/>
+            <a:ext cx="5316220" cy="8864301"/>
+          </a:xfrm>
+          <a:prstGeom prst="rect">
+            <a:avLst/>
+          </a:prstGeom>
+          <a:ln>
+            <a:noFill/>
+          </a:ln>
+          <a:extLst>
+            <a:ext uri="{53640926-AAD7-44D8-BBD7-CCE9431645EC}">
+              <a14:shadowObscured xmlns:a14="http://schemas.microsoft.com/office/drawing/2010/main"/>
+            </a:ext>
+          </a:extLst>
+        </p:spPr>
+      </p:pic>
+      <p:sp>
+        <p:nvSpPr>
+          <p:cNvPr id="5" name="CuadroTexto 4">
+            <a:extLst>
+              <a:ext uri="{FF2B5EF4-FFF2-40B4-BE49-F238E27FC236}">
+                <a16:creationId xmlns:a16="http://schemas.microsoft.com/office/drawing/2014/main" id="{20EED646-5B9F-F706-573F-57B08572CC86}"/>
+              </a:ext>
+            </a:extLst>
+          </p:cNvPr>
+          <p:cNvSpPr txBox="1"/>
+          <p:nvPr/>
+        </p:nvSpPr>
+        <p:spPr>
+          <a:xfrm>
+            <a:off x="9753600" y="4381500"/>
+            <a:ext cx="6019800" cy="1115947"/>
+          </a:xfrm>
+          <a:prstGeom prst="rect">
+            <a:avLst/>
+          </a:prstGeom>
+          <a:noFill/>
+        </p:spPr>
+        <p:txBody>
+          <a:bodyPr wrap="square">
+            <a:spAutoFit/>
+          </a:bodyPr>
+          <a:lstStyle/>
+          <a:p>
+            <a:pPr indent="450215" algn="just">
+              <a:lnSpc>
+                <a:spcPct val="200000"/>
+              </a:lnSpc>
+              <a:spcAft>
+                <a:spcPts val="800"/>
+              </a:spcAft>
+              <a:buNone/>
+            </a:pPr>
+            <a:r>
+              <a:rPr lang="es-PE" sz="1800" kern="100" dirty="0">
+                <a:effectLst/>
+                <a:latin typeface="Times New Roman" panose="02020603050405020304" pitchFamily="18" charset="0"/>
+                <a:ea typeface="Calibri" panose="020F0502020204030204" pitchFamily="34" charset="0"/>
+              </a:rPr>
+              <a:t>Diseño del Catálogo para ser aplicado en el menú (Barra para búsqueda rápida e imágenes)</a:t>
+            </a:r>
+          </a:p>
+        </p:txBody>
+      </p:sp>
+    </p:spTree>
+    <p:extLst>
+      <p:ext uri="{BB962C8B-B14F-4D97-AF65-F5344CB8AC3E}">
+        <p14:creationId xmlns:p14="http://schemas.microsoft.com/office/powerpoint/2010/main" val="808434375"/>
+      </p:ext>
+    </p:extLst>
+  </p:cSld>
+  <p:clrMapOvr>
+    <a:masterClrMapping/>
+  </p:clrMapOvr>
+</p:sld>
+</file>
+
+<file path=ppt/slides/slide12.xml><?xml version="1.0" encoding="utf-8"?>
+<p:sld xmlns:a="http://schemas.openxmlformats.org/drawingml/2006/main" xmlns:r="http://schemas.openxmlformats.org/officeDocument/2006/relationships" xmlns:p="http://schemas.openxmlformats.org/presentationml/2006/main">
+  <p:cSld>
+    <p:spTree>
+      <p:nvGrpSpPr>
+        <p:cNvPr id="1" name=""/>
+        <p:cNvGrpSpPr/>
+        <p:nvPr/>
+      </p:nvGrpSpPr>
+      <p:grpSpPr>
+        <a:xfrm>
+          <a:off x="0" y="0"/>
+          <a:ext cx="0" cy="0"/>
+          <a:chOff x="0" y="0"/>
+          <a:chExt cx="0" cy="0"/>
+        </a:xfrm>
+      </p:grpSpPr>
+      <p:pic>
+        <p:nvPicPr>
+          <p:cNvPr id="3" name="Picture 1">
+            <a:extLst>
+              <a:ext uri="{FF2B5EF4-FFF2-40B4-BE49-F238E27FC236}">
+                <a16:creationId xmlns:a16="http://schemas.microsoft.com/office/drawing/2014/main" id="{FA516C88-F363-9D50-FD00-0A04DB288443}"/>
+              </a:ext>
+            </a:extLst>
+          </p:cNvPr>
+          <p:cNvPicPr>
+            <a:picLocks noChangeAspect="1"/>
+          </p:cNvPicPr>
+          <p:nvPr/>
+        </p:nvPicPr>
+        <p:blipFill>
+          <a:blip r:embed="rId2">
+            <a:extLst>
+              <a:ext uri="{28A0092B-C50C-407E-A947-70E740481C1C}">
+                <a14:useLocalDpi xmlns:a14="http://schemas.microsoft.com/office/drawing/2010/main" val="0"/>
+              </a:ext>
+            </a:extLst>
+          </a:blip>
+          <a:stretch>
+            <a:fillRect/>
+          </a:stretch>
+        </p:blipFill>
+        <p:spPr>
+          <a:xfrm>
+            <a:off x="2286000" y="2060257"/>
+            <a:ext cx="3862070" cy="6166485"/>
+          </a:xfrm>
+          <a:prstGeom prst="rect">
+            <a:avLst/>
+          </a:prstGeom>
+        </p:spPr>
+      </p:pic>
+      <p:sp>
+        <p:nvSpPr>
+          <p:cNvPr id="5" name="CuadroTexto 4">
+            <a:extLst>
+              <a:ext uri="{FF2B5EF4-FFF2-40B4-BE49-F238E27FC236}">
+                <a16:creationId xmlns:a16="http://schemas.microsoft.com/office/drawing/2014/main" id="{A4DE2F54-2F1B-696E-48F0-39B9FE680F98}"/>
+              </a:ext>
+            </a:extLst>
+          </p:cNvPr>
+          <p:cNvSpPr txBox="1"/>
+          <p:nvPr/>
+        </p:nvSpPr>
+        <p:spPr>
+          <a:xfrm>
+            <a:off x="7567932" y="4581550"/>
+            <a:ext cx="9144000" cy="561949"/>
+          </a:xfrm>
+          <a:prstGeom prst="rect">
+            <a:avLst/>
+          </a:prstGeom>
+          <a:noFill/>
+        </p:spPr>
+        <p:txBody>
+          <a:bodyPr wrap="square">
+            <a:spAutoFit/>
+          </a:bodyPr>
+          <a:lstStyle/>
+          <a:p>
+            <a:pPr indent="450215" algn="just">
+              <a:lnSpc>
+                <a:spcPct val="200000"/>
+              </a:lnSpc>
+              <a:spcAft>
+                <a:spcPts val="800"/>
+              </a:spcAft>
+              <a:buNone/>
+            </a:pPr>
+            <a:r>
+              <a:rPr lang="es-PE" sz="1800" kern="100" dirty="0">
+                <a:effectLst/>
+                <a:latin typeface="Times New Roman" panose="02020603050405020304" pitchFamily="18" charset="0"/>
+                <a:ea typeface="Calibri" panose="020F0502020204030204" pitchFamily="34" charset="0"/>
+              </a:rPr>
+              <a:t>Diseño del Detalle de Mochila, la imagen y descripción (características, material, etc.)</a:t>
+            </a:r>
+          </a:p>
+        </p:txBody>
+      </p:sp>
+    </p:spTree>
+    <p:extLst>
+      <p:ext uri="{BB962C8B-B14F-4D97-AF65-F5344CB8AC3E}">
+        <p14:creationId xmlns:p14="http://schemas.microsoft.com/office/powerpoint/2010/main" val="157007594"/>
+      </p:ext>
+    </p:extLst>
+  </p:cSld>
+  <p:clrMapOvr>
+    <a:masterClrMapping/>
+  </p:clrMapOvr>
+</p:sld>
+</file>
+
+<file path=ppt/slides/slide13.xml><?xml version="1.0" encoding="utf-8"?>
+<p:sld xmlns:a="http://schemas.openxmlformats.org/drawingml/2006/main" xmlns:r="http://schemas.openxmlformats.org/officeDocument/2006/relationships" xmlns:p="http://schemas.openxmlformats.org/presentationml/2006/main">
+  <p:cSld>
+    <p:spTree>
+      <p:nvGrpSpPr>
+        <p:cNvPr id="1" name=""/>
+        <p:cNvGrpSpPr/>
+        <p:nvPr/>
+      </p:nvGrpSpPr>
+      <p:grpSpPr>
+        <a:xfrm>
+          <a:off x="0" y="0"/>
+          <a:ext cx="0" cy="0"/>
+          <a:chOff x="0" y="0"/>
+          <a:chExt cx="0" cy="0"/>
+        </a:xfrm>
+      </p:grpSpPr>
+      <p:pic>
+        <p:nvPicPr>
+          <p:cNvPr id="3" name="Picture 1">
+            <a:extLst>
+              <a:ext uri="{FF2B5EF4-FFF2-40B4-BE49-F238E27FC236}">
+                <a16:creationId xmlns:a16="http://schemas.microsoft.com/office/drawing/2014/main" id="{137943C4-19CD-26A5-C57B-2B7027CBCB7D}"/>
+              </a:ext>
+            </a:extLst>
+          </p:cNvPr>
+          <p:cNvPicPr>
+            <a:picLocks noChangeAspect="1"/>
+          </p:cNvPicPr>
+          <p:nvPr/>
+        </p:nvPicPr>
+        <p:blipFill>
+          <a:blip r:embed="rId2">
+            <a:extLst>
+              <a:ext uri="{28A0092B-C50C-407E-A947-70E740481C1C}">
+                <a14:useLocalDpi xmlns:a14="http://schemas.microsoft.com/office/drawing/2010/main" val="0"/>
+              </a:ext>
+            </a:extLst>
+          </a:blip>
+          <a:stretch>
+            <a:fillRect/>
+          </a:stretch>
+        </p:blipFill>
+        <p:spPr>
+          <a:xfrm>
+            <a:off x="2438400" y="2207895"/>
+            <a:ext cx="3428365" cy="5871210"/>
+          </a:xfrm>
+          <a:prstGeom prst="rect">
+            <a:avLst/>
+          </a:prstGeom>
+        </p:spPr>
+      </p:pic>
+      <p:sp>
+        <p:nvSpPr>
+          <p:cNvPr id="5" name="CuadroTexto 4">
+            <a:extLst>
+              <a:ext uri="{FF2B5EF4-FFF2-40B4-BE49-F238E27FC236}">
+                <a16:creationId xmlns:a16="http://schemas.microsoft.com/office/drawing/2014/main" id="{45F26C55-3F4F-B58A-450C-DC2638FE1690}"/>
+              </a:ext>
+            </a:extLst>
+          </p:cNvPr>
+          <p:cNvSpPr txBox="1"/>
+          <p:nvPr/>
+        </p:nvSpPr>
+        <p:spPr>
+          <a:xfrm>
+            <a:off x="7543800" y="4585526"/>
+            <a:ext cx="9144000" cy="1115947"/>
+          </a:xfrm>
+          <a:prstGeom prst="rect">
+            <a:avLst/>
+          </a:prstGeom>
+          <a:noFill/>
+        </p:spPr>
+        <p:txBody>
+          <a:bodyPr wrap="square">
+            <a:spAutoFit/>
+          </a:bodyPr>
+          <a:lstStyle/>
+          <a:p>
+            <a:pPr indent="450215" algn="just">
+              <a:lnSpc>
+                <a:spcPct val="200000"/>
+              </a:lnSpc>
+              <a:spcAft>
+                <a:spcPts val="800"/>
+              </a:spcAft>
+              <a:buNone/>
+            </a:pPr>
+            <a:r>
+              <a:rPr lang="es-PE" sz="1800" kern="100" dirty="0">
+                <a:effectLst/>
+                <a:latin typeface="Times New Roman" panose="02020603050405020304" pitchFamily="18" charset="0"/>
+                <a:ea typeface="Calibri" panose="020F0502020204030204" pitchFamily="34" charset="0"/>
+              </a:rPr>
+              <a:t>Diseño de las Ferias y Mapa, donde se usará Google </a:t>
+            </a:r>
+            <a:r>
+              <a:rPr lang="es-PE" sz="1800" kern="100" dirty="0" err="1">
+                <a:effectLst/>
+                <a:latin typeface="Times New Roman" panose="02020603050405020304" pitchFamily="18" charset="0"/>
+                <a:ea typeface="Calibri" panose="020F0502020204030204" pitchFamily="34" charset="0"/>
+              </a:rPr>
+              <a:t>Maps</a:t>
+            </a:r>
+            <a:r>
+              <a:rPr lang="es-PE" sz="1800" kern="100" dirty="0">
+                <a:effectLst/>
+                <a:latin typeface="Times New Roman" panose="02020603050405020304" pitchFamily="18" charset="0"/>
+                <a:ea typeface="Calibri" panose="020F0502020204030204" pitchFamily="34" charset="0"/>
+              </a:rPr>
+              <a:t> y se dirá donde esta ubicado con una referencia o especificación del lugar.</a:t>
+            </a:r>
+          </a:p>
+        </p:txBody>
+      </p:sp>
+    </p:spTree>
+    <p:extLst>
+      <p:ext uri="{BB962C8B-B14F-4D97-AF65-F5344CB8AC3E}">
+        <p14:creationId xmlns:p14="http://schemas.microsoft.com/office/powerpoint/2010/main" val="1898974506"/>
+      </p:ext>
+    </p:extLst>
+  </p:cSld>
+  <p:clrMapOvr>
+    <a:masterClrMapping/>
+  </p:clrMapOvr>
+</p:sld>
+</file>
+
+<file path=ppt/slides/slide14.xml><?xml version="1.0" encoding="utf-8"?>
+<p:sld xmlns:a="http://schemas.openxmlformats.org/drawingml/2006/main" xmlns:r="http://schemas.openxmlformats.org/officeDocument/2006/relationships" xmlns:p="http://schemas.openxmlformats.org/presentationml/2006/main">
+  <p:cSld>
+    <p:spTree>
+      <p:nvGrpSpPr>
+        <p:cNvPr id="1" name=""/>
+        <p:cNvGrpSpPr/>
+        <p:nvPr/>
+      </p:nvGrpSpPr>
+      <p:grpSpPr>
+        <a:xfrm>
+          <a:off x="0" y="0"/>
+          <a:ext cx="0" cy="0"/>
+          <a:chOff x="0" y="0"/>
+          <a:chExt cx="0" cy="0"/>
+        </a:xfrm>
+      </p:grpSpPr>
+      <p:pic>
+        <p:nvPicPr>
+          <p:cNvPr id="3" name="Picture 1">
+            <a:extLst>
+              <a:ext uri="{FF2B5EF4-FFF2-40B4-BE49-F238E27FC236}">
+                <a16:creationId xmlns:a16="http://schemas.microsoft.com/office/drawing/2014/main" id="{FFB4703B-485B-5295-B7C0-6ECFC1EBE33E}"/>
+              </a:ext>
+            </a:extLst>
+          </p:cNvPr>
+          <p:cNvPicPr>
+            <a:picLocks noChangeAspect="1"/>
+          </p:cNvPicPr>
+          <p:nvPr/>
+        </p:nvPicPr>
+        <p:blipFill>
+          <a:blip r:embed="rId2">
+            <a:extLst>
+              <a:ext uri="{28A0092B-C50C-407E-A947-70E740481C1C}">
+                <a14:useLocalDpi xmlns:a14="http://schemas.microsoft.com/office/drawing/2010/main" val="0"/>
+              </a:ext>
+            </a:extLst>
+          </a:blip>
+          <a:stretch>
+            <a:fillRect/>
+          </a:stretch>
+        </p:blipFill>
+        <p:spPr>
+          <a:xfrm>
+            <a:off x="2743200" y="2400300"/>
+            <a:ext cx="3582670" cy="5634990"/>
+          </a:xfrm>
+          <a:prstGeom prst="rect">
+            <a:avLst/>
+          </a:prstGeom>
+        </p:spPr>
+      </p:pic>
+      <p:sp>
+        <p:nvSpPr>
+          <p:cNvPr id="5" name="CuadroTexto 4">
+            <a:extLst>
+              <a:ext uri="{FF2B5EF4-FFF2-40B4-BE49-F238E27FC236}">
+                <a16:creationId xmlns:a16="http://schemas.microsoft.com/office/drawing/2014/main" id="{3A7652F5-6FB0-F8DF-D691-5CC3D0C44C48}"/>
+              </a:ext>
+            </a:extLst>
+          </p:cNvPr>
+          <p:cNvSpPr txBox="1"/>
+          <p:nvPr/>
+        </p:nvSpPr>
+        <p:spPr>
+          <a:xfrm>
+            <a:off x="7390132" y="4659821"/>
+            <a:ext cx="9144000" cy="1115947"/>
+          </a:xfrm>
+          <a:prstGeom prst="rect">
+            <a:avLst/>
+          </a:prstGeom>
+          <a:noFill/>
+        </p:spPr>
+        <p:txBody>
+          <a:bodyPr wrap="square">
+            <a:spAutoFit/>
+          </a:bodyPr>
+          <a:lstStyle/>
+          <a:p>
+            <a:pPr indent="450215" algn="just">
+              <a:lnSpc>
+                <a:spcPct val="200000"/>
+              </a:lnSpc>
+              <a:spcAft>
+                <a:spcPts val="800"/>
+              </a:spcAft>
+              <a:buNone/>
+            </a:pPr>
+            <a:r>
+              <a:rPr lang="es-PE" sz="1800" i="1" kern="100" dirty="0">
+                <a:effectLst/>
+                <a:latin typeface="Times New Roman" panose="02020603050405020304" pitchFamily="18" charset="0"/>
+                <a:ea typeface="Calibri" panose="020F0502020204030204" pitchFamily="34" charset="0"/>
+              </a:rPr>
+              <a:t>Diseño de Reserva y Contacto, muestra los contactos en donde iría el enlace a WhatsApp, número y correo, para cualquier contacto posible.</a:t>
+            </a:r>
+            <a:endParaRPr lang="es-PE" sz="1800" kern="100" dirty="0">
+              <a:effectLst/>
+              <a:latin typeface="Times New Roman" panose="02020603050405020304" pitchFamily="18" charset="0"/>
+              <a:ea typeface="Calibri" panose="020F0502020204030204" pitchFamily="34" charset="0"/>
+            </a:endParaRPr>
+          </a:p>
+        </p:txBody>
+      </p:sp>
+    </p:spTree>
+    <p:extLst>
+      <p:ext uri="{BB962C8B-B14F-4D97-AF65-F5344CB8AC3E}">
+        <p14:creationId xmlns:p14="http://schemas.microsoft.com/office/powerpoint/2010/main" val="1320818334"/>
+      </p:ext>
+    </p:extLst>
+  </p:cSld>
+  <p:clrMapOvr>
+    <a:masterClrMapping/>
+  </p:clrMapOvr>
+</p:sld>
+</file>
+
+<file path=ppt/slides/slide15.xml><?xml version="1.0" encoding="utf-8"?>
+<p:sld xmlns:a="http://schemas.openxmlformats.org/drawingml/2006/main" xmlns:r="http://schemas.openxmlformats.org/officeDocument/2006/relationships" xmlns:p="http://schemas.openxmlformats.org/presentationml/2006/main">
+  <p:cSld>
+    <p:spTree>
+      <p:nvGrpSpPr>
+        <p:cNvPr id="1" name=""/>
+        <p:cNvGrpSpPr/>
+        <p:nvPr/>
+      </p:nvGrpSpPr>
+      <p:grpSpPr>
+        <a:xfrm>
+          <a:off x="0" y="0"/>
+          <a:ext cx="0" cy="0"/>
+          <a:chOff x="0" y="0"/>
+          <a:chExt cx="0" cy="0"/>
+        </a:xfrm>
+      </p:grpSpPr>
+      <p:pic>
+        <p:nvPicPr>
+          <p:cNvPr id="3" name="Picture 1">
+            <a:extLst>
+              <a:ext uri="{FF2B5EF4-FFF2-40B4-BE49-F238E27FC236}">
+                <a16:creationId xmlns:a16="http://schemas.microsoft.com/office/drawing/2014/main" id="{603D9550-DF5D-F2D2-3A79-285689629726}"/>
+              </a:ext>
+            </a:extLst>
+          </p:cNvPr>
+          <p:cNvPicPr>
+            <a:picLocks noChangeAspect="1"/>
+          </p:cNvPicPr>
+          <p:nvPr/>
+        </p:nvPicPr>
+        <p:blipFill>
+          <a:blip r:embed="rId2">
+            <a:extLst>
+              <a:ext uri="{28A0092B-C50C-407E-A947-70E740481C1C}">
+                <a14:useLocalDpi xmlns:a14="http://schemas.microsoft.com/office/drawing/2010/main" val="0"/>
+              </a:ext>
+            </a:extLst>
+          </a:blip>
+          <a:stretch>
+            <a:fillRect/>
+          </a:stretch>
+        </p:blipFill>
+        <p:spPr>
+          <a:xfrm>
+            <a:off x="1905000" y="1181100"/>
+            <a:ext cx="5486400" cy="7725703"/>
+          </a:xfrm>
+          <a:prstGeom prst="rect">
+            <a:avLst/>
+          </a:prstGeom>
+        </p:spPr>
+      </p:pic>
+      <p:sp>
+        <p:nvSpPr>
+          <p:cNvPr id="5" name="CuadroTexto 4">
+            <a:extLst>
+              <a:ext uri="{FF2B5EF4-FFF2-40B4-BE49-F238E27FC236}">
+                <a16:creationId xmlns:a16="http://schemas.microsoft.com/office/drawing/2014/main" id="{551CD642-D4BD-B4B2-677D-48B8E6B80509}"/>
+              </a:ext>
+            </a:extLst>
+          </p:cNvPr>
+          <p:cNvSpPr txBox="1"/>
+          <p:nvPr/>
+        </p:nvSpPr>
+        <p:spPr>
+          <a:xfrm>
+            <a:off x="7924800" y="4485977"/>
+            <a:ext cx="9144000" cy="1115947"/>
+          </a:xfrm>
+          <a:prstGeom prst="rect">
+            <a:avLst/>
+          </a:prstGeom>
+          <a:noFill/>
+        </p:spPr>
+        <p:txBody>
+          <a:bodyPr wrap="square">
+            <a:spAutoFit/>
+          </a:bodyPr>
+          <a:lstStyle/>
+          <a:p>
+            <a:pPr marL="6985" indent="450215" algn="just">
+              <a:lnSpc>
+                <a:spcPct val="200000"/>
+              </a:lnSpc>
+              <a:spcAft>
+                <a:spcPts val="800"/>
+              </a:spcAft>
+              <a:buNone/>
+            </a:pPr>
+            <a:r>
+              <a:rPr lang="es-PE" sz="1800" kern="100" dirty="0">
+                <a:effectLst/>
+                <a:latin typeface="Times New Roman" panose="02020603050405020304" pitchFamily="18" charset="0"/>
+                <a:ea typeface="Calibri" panose="020F0502020204030204" pitchFamily="34" charset="0"/>
+              </a:rPr>
+              <a:t>Diseño para el Panel de Administrador, en el que se controlará el Inventario y las Nuevas Ferias que desee añadir o remover</a:t>
+            </a:r>
+            <a:r>
+              <a:rPr lang="es-PE" sz="1800" i="1" kern="100" dirty="0">
+                <a:effectLst/>
+                <a:latin typeface="Times New Roman" panose="02020603050405020304" pitchFamily="18" charset="0"/>
+                <a:ea typeface="Calibri" panose="020F0502020204030204" pitchFamily="34" charset="0"/>
+              </a:rPr>
+              <a:t>.</a:t>
+            </a:r>
+            <a:endParaRPr lang="es-PE" sz="1800" kern="100" dirty="0">
+              <a:effectLst/>
+              <a:latin typeface="Times New Roman" panose="02020603050405020304" pitchFamily="18" charset="0"/>
+              <a:ea typeface="Calibri" panose="020F0502020204030204" pitchFamily="34" charset="0"/>
+            </a:endParaRPr>
+          </a:p>
+        </p:txBody>
+      </p:sp>
+    </p:spTree>
+    <p:extLst>
+      <p:ext uri="{BB962C8B-B14F-4D97-AF65-F5344CB8AC3E}">
+        <p14:creationId xmlns:p14="http://schemas.microsoft.com/office/powerpoint/2010/main" val="1910417170"/>
+      </p:ext>
+    </p:extLst>
+  </p:cSld>
+  <p:clrMapOvr>
+    <a:masterClrMapping/>
+  </p:clrMapOvr>
+</p:sld>
+</file>
+
+<file path=ppt/slides/slide16.xml><?xml version="1.0" encoding="utf-8"?>
+<p:sld xmlns:a="http://schemas.openxmlformats.org/drawingml/2006/main" xmlns:r="http://schemas.openxmlformats.org/officeDocument/2006/relationships" xmlns:p="http://schemas.openxmlformats.org/presentationml/2006/main" showMasterSp="0">
+  <p:cSld>
+    <p:spTree>
+      <p:nvGrpSpPr>
+        <p:cNvPr id="1" name=""/>
+        <p:cNvGrpSpPr/>
+        <p:nvPr/>
+      </p:nvGrpSpPr>
+      <p:grpSpPr>
+        <a:xfrm>
+          <a:off x="0" y="0"/>
+          <a:ext cx="0" cy="0"/>
+          <a:chOff x="0" y="0"/>
+          <a:chExt cx="0" cy="0"/>
+        </a:xfrm>
+      </p:grpSpPr>
+      <p:sp>
+        <p:nvSpPr>
+          <p:cNvPr id="2" name="object 2"/>
+          <p:cNvSpPr/>
+          <p:nvPr/>
+        </p:nvSpPr>
+        <p:spPr>
+          <a:xfrm>
+            <a:off x="1143000" y="1409700"/>
+            <a:ext cx="14935200" cy="139065"/>
+          </a:xfrm>
+          <a:custGeom>
+            <a:avLst/>
+            <a:gdLst/>
+            <a:ahLst/>
+            <a:cxnLst/>
+            <a:rect l="l" t="t" r="r" b="b"/>
+            <a:pathLst>
+              <a:path w="14935200" h="139065">
+                <a:moveTo>
+                  <a:pt x="14935073" y="0"/>
+                </a:moveTo>
+                <a:lnTo>
+                  <a:pt x="0" y="44196"/>
+                </a:lnTo>
+                <a:lnTo>
+                  <a:pt x="88" y="139065"/>
+                </a:lnTo>
+                <a:lnTo>
+                  <a:pt x="14935073" y="94869"/>
+                </a:lnTo>
+                <a:lnTo>
+                  <a:pt x="14935073" y="0"/>
+                </a:lnTo>
+                <a:close/>
+              </a:path>
+            </a:pathLst>
+          </a:custGeom>
+          <a:solidFill>
+            <a:srgbClr val="000000"/>
+          </a:solidFill>
+        </p:spPr>
+        <p:txBody>
+          <a:bodyPr wrap="square" lIns="0" tIns="0" rIns="0" bIns="0" rtlCol="0"/>
+          <a:lstStyle/>
+          <a:p>
+            <a:endParaRPr/>
+          </a:p>
+        </p:txBody>
+      </p:sp>
+      <p:sp>
+        <p:nvSpPr>
+          <p:cNvPr id="3" name="object 3" descr="$PPTXTitle"/>
+          <p:cNvSpPr txBox="1">
+            <a:spLocks noGrp="1"/>
+          </p:cNvSpPr>
+          <p:nvPr>
+            <p:ph type="title"/>
+          </p:nvPr>
+        </p:nvSpPr>
+        <p:spPr>
+          <a:prstGeom prst="rect">
+            <a:avLst/>
+          </a:prstGeom>
+        </p:spPr>
+        <p:txBody>
+          <a:bodyPr vert="horz" wrap="square" lIns="0" tIns="333247" rIns="0" bIns="0" rtlCol="0">
+            <a:spAutoFit/>
+          </a:bodyPr>
+          <a:lstStyle/>
+          <a:p>
+            <a:pPr marL="200660">
+              <a:lnSpc>
+                <a:spcPct val="100000"/>
+              </a:lnSpc>
+              <a:spcBef>
+                <a:spcPts val="100"/>
+              </a:spcBef>
+            </a:pPr>
+            <a:r>
+              <a:rPr dirty="0"/>
+              <a:t>9.</a:t>
+            </a:r>
+            <a:r>
+              <a:rPr spc="-200" dirty="0"/>
+              <a:t> </a:t>
+            </a:r>
+            <a:r>
+              <a:rPr dirty="0"/>
+              <a:t>Referencias</a:t>
+            </a:r>
+            <a:r>
+              <a:rPr spc="-150" dirty="0"/>
+              <a:t> </a:t>
+            </a:r>
+            <a:r>
+              <a:rPr spc="-10" dirty="0"/>
+              <a:t>Bibliograficas</a:t>
+            </a:r>
+          </a:p>
+        </p:txBody>
+      </p:sp>
+      <p:sp>
+        <p:nvSpPr>
+          <p:cNvPr id="5" name="CuadroTexto 4">
+            <a:extLst>
+              <a:ext uri="{FF2B5EF4-FFF2-40B4-BE49-F238E27FC236}">
+                <a16:creationId xmlns:a16="http://schemas.microsoft.com/office/drawing/2014/main" id="{DCAE3338-8298-1EC2-3599-BDB9115029F9}"/>
+              </a:ext>
+            </a:extLst>
+          </p:cNvPr>
+          <p:cNvSpPr txBox="1"/>
+          <p:nvPr/>
+        </p:nvSpPr>
+        <p:spPr>
+          <a:xfrm>
+            <a:off x="1143000" y="2783110"/>
+            <a:ext cx="9144000" cy="3885936"/>
+          </a:xfrm>
+          <a:prstGeom prst="rect">
+            <a:avLst/>
+          </a:prstGeom>
+          <a:noFill/>
+        </p:spPr>
+        <p:txBody>
+          <a:bodyPr wrap="square">
+            <a:spAutoFit/>
+          </a:bodyPr>
+          <a:lstStyle/>
+          <a:p>
+            <a:pPr algn="just">
+              <a:lnSpc>
+                <a:spcPct val="200000"/>
+              </a:lnSpc>
+              <a:buNone/>
+            </a:pPr>
+            <a:r>
+              <a:rPr lang="es-PE" dirty="0">
+                <a:effectLst/>
+                <a:latin typeface="Times New Roman" panose="02020603050405020304" pitchFamily="18" charset="0"/>
+                <a:cs typeface="Times New Roman" panose="02020603050405020304" pitchFamily="18" charset="0"/>
+              </a:rPr>
+              <a:t>Instituto Nacional de Estadística e Informática. (2023). </a:t>
+            </a:r>
+            <a:r>
+              <a:rPr lang="es-PE" i="1" dirty="0">
+                <a:effectLst/>
+                <a:latin typeface="Times New Roman" panose="02020603050405020304" pitchFamily="18" charset="0"/>
+                <a:cs typeface="Times New Roman" panose="02020603050405020304" pitchFamily="18" charset="0"/>
+              </a:rPr>
+              <a:t>Encuesta Nacional de Mercados de Abastos y Comercio Local en el Perú</a:t>
+            </a:r>
+            <a:r>
+              <a:rPr lang="es-PE" dirty="0">
+                <a:effectLst/>
+                <a:latin typeface="Times New Roman" panose="02020603050405020304" pitchFamily="18" charset="0"/>
+                <a:cs typeface="Times New Roman" panose="02020603050405020304" pitchFamily="18" charset="0"/>
+              </a:rPr>
+              <a:t>.</a:t>
+            </a:r>
+          </a:p>
+          <a:p>
+            <a:pPr algn="just">
+              <a:lnSpc>
+                <a:spcPct val="200000"/>
+              </a:lnSpc>
+              <a:buNone/>
+            </a:pPr>
+            <a:r>
+              <a:rPr lang="es-PE" dirty="0">
+                <a:effectLst/>
+                <a:latin typeface="Times New Roman" panose="02020603050405020304" pitchFamily="18" charset="0"/>
+                <a:cs typeface="Times New Roman" panose="02020603050405020304" pitchFamily="18" charset="0"/>
+              </a:rPr>
+              <a:t>Ministerio de la Producción. (2024). </a:t>
+            </a:r>
+            <a:r>
+              <a:rPr lang="es-PE" i="1" dirty="0">
+                <a:effectLst/>
+                <a:latin typeface="Times New Roman" panose="02020603050405020304" pitchFamily="18" charset="0"/>
+                <a:cs typeface="Times New Roman" panose="02020603050405020304" pitchFamily="18" charset="0"/>
+              </a:rPr>
+              <a:t>PRODUCE</a:t>
+            </a:r>
+            <a:r>
+              <a:rPr lang="es-PE" dirty="0">
+                <a:effectLst/>
+                <a:latin typeface="Times New Roman" panose="02020603050405020304" pitchFamily="18" charset="0"/>
+                <a:cs typeface="Times New Roman" panose="02020603050405020304" pitchFamily="18" charset="0"/>
+              </a:rPr>
+              <a:t>. Gobierno del Perú. </a:t>
+            </a:r>
+            <a:r>
+              <a:rPr lang="es-PE" dirty="0">
+                <a:effectLst/>
+                <a:latin typeface="Times New Roman" panose="02020603050405020304" pitchFamily="18" charset="0"/>
+                <a:cs typeface="Times New Roman" panose="02020603050405020304" pitchFamily="18" charset="0"/>
+                <a:hlinkClick r:id="rId2"/>
+              </a:rPr>
+              <a:t>https://www.gob.pe/produce</a:t>
+            </a:r>
+            <a:endParaRPr lang="es-PE" dirty="0">
+              <a:effectLst/>
+              <a:latin typeface="Times New Roman" panose="02020603050405020304" pitchFamily="18" charset="0"/>
+              <a:cs typeface="Times New Roman" panose="02020603050405020304" pitchFamily="18" charset="0"/>
+            </a:endParaRPr>
+          </a:p>
+          <a:p>
+            <a:pPr algn="just">
+              <a:lnSpc>
+                <a:spcPct val="200000"/>
+              </a:lnSpc>
+              <a:buNone/>
+            </a:pPr>
+            <a:r>
+              <a:rPr lang="es-PE" dirty="0">
+                <a:effectLst/>
+                <a:latin typeface="Times New Roman" panose="02020603050405020304" pitchFamily="18" charset="0"/>
+                <a:cs typeface="Times New Roman" panose="02020603050405020304" pitchFamily="18" charset="0"/>
+              </a:rPr>
+              <a:t>Mozilla Developer Network. (2024). </a:t>
+            </a:r>
+            <a:r>
+              <a:rPr lang="es-PE" i="1" dirty="0">
+                <a:effectLst/>
+                <a:latin typeface="Times New Roman" panose="02020603050405020304" pitchFamily="18" charset="0"/>
+                <a:cs typeface="Times New Roman" panose="02020603050405020304" pitchFamily="18" charset="0"/>
+              </a:rPr>
+              <a:t>Fundamentos de Accesibilidad Web</a:t>
+            </a:r>
+            <a:r>
+              <a:rPr lang="es-PE" dirty="0">
+                <a:effectLst/>
+                <a:latin typeface="Times New Roman" panose="02020603050405020304" pitchFamily="18" charset="0"/>
+                <a:cs typeface="Times New Roman" panose="02020603050405020304" pitchFamily="18" charset="0"/>
+              </a:rPr>
+              <a:t>. MDN Web Docs. </a:t>
+            </a:r>
+            <a:r>
+              <a:rPr lang="es-PE" dirty="0">
+                <a:effectLst/>
+                <a:latin typeface="Times New Roman" panose="02020603050405020304" pitchFamily="18" charset="0"/>
+                <a:cs typeface="Times New Roman" panose="02020603050405020304" pitchFamily="18" charset="0"/>
+                <a:hlinkClick r:id="rId3"/>
+              </a:rPr>
+              <a:t>https://developer.mozilla.org/es/docs/Learn/Accessibility</a:t>
+            </a:r>
+            <a:endParaRPr lang="es-PE" dirty="0">
+              <a:effectLst/>
+              <a:latin typeface="Times New Roman" panose="02020603050405020304" pitchFamily="18" charset="0"/>
+              <a:cs typeface="Times New Roman" panose="02020603050405020304" pitchFamily="18" charset="0"/>
+            </a:endParaRPr>
+          </a:p>
+          <a:p>
+            <a:pPr algn="just">
+              <a:lnSpc>
+                <a:spcPct val="200000"/>
+              </a:lnSpc>
+              <a:buNone/>
+            </a:pPr>
+            <a:r>
+              <a:rPr lang="es-PE" dirty="0">
+                <a:effectLst/>
+                <a:latin typeface="Times New Roman" panose="02020603050405020304" pitchFamily="18" charset="0"/>
+                <a:cs typeface="Times New Roman" panose="02020603050405020304" pitchFamily="18" charset="0"/>
+              </a:rPr>
+              <a:t>Node.js </a:t>
+            </a:r>
+            <a:r>
+              <a:rPr lang="es-PE" dirty="0" err="1">
+                <a:effectLst/>
+                <a:latin typeface="Times New Roman" panose="02020603050405020304" pitchFamily="18" charset="0"/>
+                <a:cs typeface="Times New Roman" panose="02020603050405020304" pitchFamily="18" charset="0"/>
+              </a:rPr>
+              <a:t>Foundation</a:t>
+            </a:r>
+            <a:r>
+              <a:rPr lang="es-PE" dirty="0">
+                <a:effectLst/>
+                <a:latin typeface="Times New Roman" panose="02020603050405020304" pitchFamily="18" charset="0"/>
+                <a:cs typeface="Times New Roman" panose="02020603050405020304" pitchFamily="18" charset="0"/>
+              </a:rPr>
+              <a:t>. (2024). </a:t>
+            </a:r>
+            <a:r>
+              <a:rPr lang="es-PE" i="1" dirty="0">
+                <a:effectLst/>
+                <a:latin typeface="Times New Roman" panose="02020603050405020304" pitchFamily="18" charset="0"/>
+                <a:cs typeface="Times New Roman" panose="02020603050405020304" pitchFamily="18" charset="0"/>
+              </a:rPr>
+              <a:t>Documentación oficial de Express.js</a:t>
+            </a:r>
+            <a:r>
+              <a:rPr lang="es-PE" dirty="0">
+                <a:effectLst/>
+                <a:latin typeface="Times New Roman" panose="02020603050405020304" pitchFamily="18" charset="0"/>
+                <a:cs typeface="Times New Roman" panose="02020603050405020304" pitchFamily="18" charset="0"/>
+              </a:rPr>
+              <a:t>. </a:t>
+            </a:r>
+            <a:r>
+              <a:rPr lang="es-PE" dirty="0" err="1">
+                <a:effectLst/>
+                <a:latin typeface="Times New Roman" panose="02020603050405020304" pitchFamily="18" charset="0"/>
+                <a:cs typeface="Times New Roman" panose="02020603050405020304" pitchFamily="18" charset="0"/>
+              </a:rPr>
+              <a:t>OpenJS</a:t>
+            </a:r>
+            <a:r>
+              <a:rPr lang="es-PE" dirty="0">
+                <a:effectLst/>
+                <a:latin typeface="Times New Roman" panose="02020603050405020304" pitchFamily="18" charset="0"/>
+                <a:cs typeface="Times New Roman" panose="02020603050405020304" pitchFamily="18" charset="0"/>
+              </a:rPr>
+              <a:t> </a:t>
+            </a:r>
+            <a:r>
+              <a:rPr lang="es-PE" dirty="0" err="1">
+                <a:effectLst/>
+                <a:latin typeface="Times New Roman" panose="02020603050405020304" pitchFamily="18" charset="0"/>
+                <a:cs typeface="Times New Roman" panose="02020603050405020304" pitchFamily="18" charset="0"/>
+              </a:rPr>
+              <a:t>Foundation</a:t>
+            </a:r>
+            <a:r>
+              <a:rPr lang="es-PE" dirty="0">
+                <a:effectLst/>
+                <a:latin typeface="Times New Roman" panose="02020603050405020304" pitchFamily="18" charset="0"/>
+                <a:cs typeface="Times New Roman" panose="02020603050405020304" pitchFamily="18" charset="0"/>
+              </a:rPr>
+              <a:t>. </a:t>
+            </a:r>
+            <a:r>
+              <a:rPr lang="es-PE" dirty="0">
+                <a:effectLst/>
+                <a:latin typeface="Times New Roman" panose="02020603050405020304" pitchFamily="18" charset="0"/>
+                <a:cs typeface="Times New Roman" panose="02020603050405020304" pitchFamily="18" charset="0"/>
+                <a:hlinkClick r:id="rId4"/>
+              </a:rPr>
+              <a:t>https://expressjs.com/es/</a:t>
+            </a:r>
+            <a:endParaRPr lang="es-PE" dirty="0">
+              <a:effectLst/>
+              <a:latin typeface="Times New Roman" panose="02020603050405020304" pitchFamily="18" charset="0"/>
+              <a:cs typeface="Times New Roman" panose="02020603050405020304" pitchFamily="18" charset="0"/>
+            </a:endParaRPr>
+          </a:p>
+        </p:txBody>
+      </p:sp>
+    </p:spTree>
+  </p:cSld>
+  <p:clrMapOvr>
+    <a:masterClrMapping/>
+  </p:clrMapOvr>
+</p:sld>
+</file>
+
+<file path=ppt/slides/slide17.xml><?xml version="1.0" encoding="utf-8"?>
 <p:sld xmlns:a="http://schemas.openxmlformats.org/drawingml/2006/main" xmlns:r="http://schemas.openxmlformats.org/officeDocument/2006/relationships" xmlns:p="http://schemas.openxmlformats.org/presentationml/2006/main" showMasterSp="0">
   <p:cSld>
     <p:spTree>
@@ -4596,7 +5725,7 @@
 </file>
 
 <file path=ppt/slides/slide9.xml><?xml version="1.0" encoding="utf-8"?>
-<p:sld xmlns:a="http://schemas.openxmlformats.org/drawingml/2006/main" xmlns:r="http://schemas.openxmlformats.org/officeDocument/2006/relationships" xmlns:p="http://schemas.openxmlformats.org/presentationml/2006/main" showMasterSp="0">
+<p:sld xmlns:a="http://schemas.openxmlformats.org/drawingml/2006/main" xmlns:r="http://schemas.openxmlformats.org/officeDocument/2006/relationships" xmlns:p="http://schemas.openxmlformats.org/presentationml/2006/main">
   <p:cSld>
     <p:spTree>
       <p:nvGrpSpPr>
@@ -4612,114 +5741,48 @@
           <a:chExt cx="0" cy="0"/>
         </a:xfrm>
       </p:grpSpPr>
-      <p:sp>
-        <p:nvSpPr>
-          <p:cNvPr id="2" name="object 2"/>
-          <p:cNvSpPr/>
+      <p:pic>
+        <p:nvPicPr>
+          <p:cNvPr id="3" name="Picture 1">
+            <a:extLst>
+              <a:ext uri="{FF2B5EF4-FFF2-40B4-BE49-F238E27FC236}">
+                <a16:creationId xmlns:a16="http://schemas.microsoft.com/office/drawing/2014/main" id="{FDD540C1-DFE3-8DB8-DA47-F2943CB07DFE}"/>
+              </a:ext>
+            </a:extLst>
+          </p:cNvPr>
+          <p:cNvPicPr>
+            <a:picLocks noChangeAspect="1"/>
+          </p:cNvPicPr>
           <p:nvPr/>
-        </p:nvSpPr>
+        </p:nvPicPr>
+        <p:blipFill>
+          <a:blip r:embed="rId2" cstate="print">
+            <a:extLst>
+              <a:ext uri="{28A0092B-C50C-407E-A947-70E740481C1C}">
+                <a14:useLocalDpi xmlns:a14="http://schemas.microsoft.com/office/drawing/2010/main" val="0"/>
+              </a:ext>
+            </a:extLst>
+          </a:blip>
+          <a:stretch>
+            <a:fillRect/>
+          </a:stretch>
+        </p:blipFill>
         <p:spPr>
           <a:xfrm>
-            <a:off x="1143000" y="1409700"/>
-            <a:ext cx="14935200" cy="139065"/>
+            <a:off x="4114800" y="2857500"/>
+            <a:ext cx="11200692" cy="5734367"/>
           </a:xfrm>
-          <a:custGeom>
-            <a:avLst/>
-            <a:gdLst/>
-            <a:ahLst/>
-            <a:cxnLst/>
-            <a:rect l="l" t="t" r="r" b="b"/>
-            <a:pathLst>
-              <a:path w="14935200" h="139065">
-                <a:moveTo>
-                  <a:pt x="14935073" y="0"/>
-                </a:moveTo>
-                <a:lnTo>
-                  <a:pt x="0" y="44196"/>
-                </a:lnTo>
-                <a:lnTo>
-                  <a:pt x="88" y="139065"/>
-                </a:lnTo>
-                <a:lnTo>
-                  <a:pt x="14935073" y="94869"/>
-                </a:lnTo>
-                <a:lnTo>
-                  <a:pt x="14935073" y="0"/>
-                </a:lnTo>
-                <a:close/>
-              </a:path>
-            </a:pathLst>
-          </a:custGeom>
-          <a:solidFill>
-            <a:srgbClr val="000000"/>
-          </a:solidFill>
-        </p:spPr>
-        <p:txBody>
-          <a:bodyPr wrap="square" lIns="0" tIns="0" rIns="0" bIns="0" rtlCol="0"/>
-          <a:lstStyle/>
-          <a:p>
-            <a:endParaRPr/>
-          </a:p>
-        </p:txBody>
-      </p:sp>
-      <p:sp>
-        <p:nvSpPr>
-          <p:cNvPr id="3" name="object 3" descr="$PPTXTitle"/>
-          <p:cNvSpPr txBox="1">
-            <a:spLocks noGrp="1"/>
-          </p:cNvSpPr>
-          <p:nvPr>
-            <p:ph type="title"/>
-          </p:nvPr>
-        </p:nvSpPr>
-        <p:spPr>
           <a:prstGeom prst="rect">
             <a:avLst/>
           </a:prstGeom>
         </p:spPr>
-        <p:txBody>
-          <a:bodyPr vert="horz" wrap="square" lIns="0" tIns="333247" rIns="0" bIns="0" rtlCol="0">
-            <a:spAutoFit/>
-          </a:bodyPr>
-          <a:lstStyle/>
-          <a:p>
-            <a:pPr marL="200660">
-              <a:lnSpc>
-                <a:spcPct val="100000"/>
-              </a:lnSpc>
-              <a:spcBef>
-                <a:spcPts val="100"/>
-              </a:spcBef>
-            </a:pPr>
-            <a:r>
-              <a:rPr dirty="0"/>
-              <a:t>9.</a:t>
-            </a:r>
-            <a:r>
-              <a:rPr spc="-200" dirty="0"/>
-              <a:t> </a:t>
-            </a:r>
-            <a:r>
-              <a:rPr dirty="0"/>
-              <a:t>Referencias</a:t>
-            </a:r>
-            <a:r>
-              <a:rPr spc="-150" dirty="0"/>
-              <a:t> </a:t>
-            </a:r>
-            <a:r>
-              <a:rPr spc="-10" dirty="0"/>
-              <a:t>Bibliograficas</a:t>
-            </a:r>
-          </a:p>
-        </p:txBody>
-      </p:sp>
+      </p:pic>
       <p:sp>
         <p:nvSpPr>
-          <p:cNvPr id="5" name="CuadroTexto 4">
+          <p:cNvPr id="6" name="CuadroTexto 5">
             <a:extLst>
               <a:ext uri="{FF2B5EF4-FFF2-40B4-BE49-F238E27FC236}">
-                <a16:creationId xmlns:a16="http://schemas.microsoft.com/office/drawing/2014/main" id="{DCAE3338-8298-1EC2-3599-BDB9115029F9}"/>
+                <a16:creationId xmlns:a16="http://schemas.microsoft.com/office/drawing/2014/main" id="{42A86620-6CE0-F89B-1BA5-D781A557E015}"/>
               </a:ext>
             </a:extLst>
           </p:cNvPr>
@@ -4728,8 +5791,8 @@
         </p:nvSpPr>
         <p:spPr>
           <a:xfrm>
-            <a:off x="1143000" y="2783110"/>
-            <a:ext cx="9144000" cy="3885936"/>
+            <a:off x="4343400" y="1866900"/>
+            <a:ext cx="9144000" cy="561949"/>
           </a:xfrm>
           <a:prstGeom prst="rect">
             <a:avLst/>
@@ -4742,226 +5805,40 @@
           </a:bodyPr>
           <a:lstStyle/>
           <a:p>
-            <a:pPr algn="just">
+            <a:pPr indent="450215" algn="just">
               <a:lnSpc>
                 <a:spcPct val="200000"/>
               </a:lnSpc>
+              <a:spcAft>
+                <a:spcPts val="800"/>
+              </a:spcAft>
               <a:buNone/>
             </a:pPr>
             <a:r>
-              <a:rPr lang="es-PE" dirty="0">
-                <a:effectLst/>
+              <a:rPr lang="es-PE" sz="1800" b="1" dirty="0">
                 <a:latin typeface="Times New Roman" panose="02020603050405020304" pitchFamily="18" charset="0"/>
                 <a:cs typeface="Times New Roman" panose="02020603050405020304" pitchFamily="18" charset="0"/>
               </a:rPr>
-              <a:t>Instituto Nacional de Estadística e Informática. (2023). </a:t>
-            </a:r>
-            <a:r>
-              <a:rPr lang="es-PE" i="1" dirty="0">
-                <a:effectLst/>
-                <a:latin typeface="Times New Roman" panose="02020603050405020304" pitchFamily="18" charset="0"/>
+              <a:t>Diagrama Detallado de la Arquitectura Cliente – Servidor</a:t>
+            </a:r>
+            <a:r>
+              <a:rPr lang="es-PE" sz="1800" b="1" kern="100" dirty="0">
+                <a:effectLst/>
+                <a:latin typeface="Times New Roman" panose="02020603050405020304" pitchFamily="18" charset="0"/>
+                <a:ea typeface="Calibri" panose="020F0502020204030204" pitchFamily="34" charset="0"/>
                 <a:cs typeface="Times New Roman" panose="02020603050405020304" pitchFamily="18" charset="0"/>
               </a:rPr>
-              <a:t>Encuesta Nacional de Mercados de Abastos y Comercio Local en el Perú</a:t>
-            </a:r>
-            <a:r>
-              <a:rPr lang="es-PE" dirty="0">
-                <a:effectLst/>
-                <a:latin typeface="Times New Roman" panose="02020603050405020304" pitchFamily="18" charset="0"/>
-                <a:cs typeface="Times New Roman" panose="02020603050405020304" pitchFamily="18" charset="0"/>
-              </a:rPr>
-              <a:t>.</a:t>
-            </a:r>
-          </a:p>
-          <a:p>
-            <a:pPr algn="just">
-              <a:lnSpc>
-                <a:spcPct val="200000"/>
-              </a:lnSpc>
-              <a:buNone/>
-            </a:pPr>
-            <a:r>
-              <a:rPr lang="es-PE" dirty="0">
-                <a:effectLst/>
-                <a:latin typeface="Times New Roman" panose="02020603050405020304" pitchFamily="18" charset="0"/>
-                <a:cs typeface="Times New Roman" panose="02020603050405020304" pitchFamily="18" charset="0"/>
-              </a:rPr>
-              <a:t>Ministerio de la Producción. (2024). </a:t>
-            </a:r>
-            <a:r>
-              <a:rPr lang="es-PE" i="1" dirty="0">
-                <a:effectLst/>
-                <a:latin typeface="Times New Roman" panose="02020603050405020304" pitchFamily="18" charset="0"/>
-                <a:cs typeface="Times New Roman" panose="02020603050405020304" pitchFamily="18" charset="0"/>
-              </a:rPr>
-              <a:t>PRODUCE</a:t>
-            </a:r>
-            <a:r>
-              <a:rPr lang="es-PE" dirty="0">
-                <a:effectLst/>
-                <a:latin typeface="Times New Roman" panose="02020603050405020304" pitchFamily="18" charset="0"/>
-                <a:cs typeface="Times New Roman" panose="02020603050405020304" pitchFamily="18" charset="0"/>
-              </a:rPr>
-              <a:t>. Gobierno del Perú. </a:t>
-            </a:r>
-            <a:r>
-              <a:rPr lang="es-PE" dirty="0">
-                <a:effectLst/>
-                <a:latin typeface="Times New Roman" panose="02020603050405020304" pitchFamily="18" charset="0"/>
-                <a:cs typeface="Times New Roman" panose="02020603050405020304" pitchFamily="18" charset="0"/>
-                <a:hlinkClick r:id="rId2"/>
-              </a:rPr>
-              <a:t>https://www.gob.pe/produce</a:t>
-            </a:r>
-            <a:endParaRPr lang="es-PE" dirty="0">
-              <a:effectLst/>
-              <a:latin typeface="Times New Roman" panose="02020603050405020304" pitchFamily="18" charset="0"/>
-              <a:cs typeface="Times New Roman" panose="02020603050405020304" pitchFamily="18" charset="0"/>
-            </a:endParaRPr>
-          </a:p>
-          <a:p>
-            <a:pPr algn="just">
-              <a:lnSpc>
-                <a:spcPct val="200000"/>
-              </a:lnSpc>
-              <a:buNone/>
-            </a:pPr>
-            <a:r>
-              <a:rPr lang="es-PE" dirty="0">
-                <a:effectLst/>
-                <a:latin typeface="Times New Roman" panose="02020603050405020304" pitchFamily="18" charset="0"/>
-                <a:cs typeface="Times New Roman" panose="02020603050405020304" pitchFamily="18" charset="0"/>
-              </a:rPr>
-              <a:t>Mozilla Developer Network. (2024). </a:t>
-            </a:r>
-            <a:r>
-              <a:rPr lang="es-PE" i="1" dirty="0">
-                <a:effectLst/>
-                <a:latin typeface="Times New Roman" panose="02020603050405020304" pitchFamily="18" charset="0"/>
-                <a:cs typeface="Times New Roman" panose="02020603050405020304" pitchFamily="18" charset="0"/>
-              </a:rPr>
-              <a:t>Fundamentos de Accesibilidad Web</a:t>
-            </a:r>
-            <a:r>
-              <a:rPr lang="es-PE" dirty="0">
-                <a:effectLst/>
-                <a:latin typeface="Times New Roman" panose="02020603050405020304" pitchFamily="18" charset="0"/>
-                <a:cs typeface="Times New Roman" panose="02020603050405020304" pitchFamily="18" charset="0"/>
-              </a:rPr>
-              <a:t>. MDN Web Docs. </a:t>
-            </a:r>
-            <a:r>
-              <a:rPr lang="es-PE" dirty="0">
-                <a:effectLst/>
-                <a:latin typeface="Times New Roman" panose="02020603050405020304" pitchFamily="18" charset="0"/>
-                <a:cs typeface="Times New Roman" panose="02020603050405020304" pitchFamily="18" charset="0"/>
-                <a:hlinkClick r:id="rId3"/>
-              </a:rPr>
-              <a:t>https://developer.mozilla.org/es/docs/Learn/Accessibility</a:t>
-            </a:r>
-            <a:endParaRPr lang="es-PE" dirty="0">
-              <a:effectLst/>
-              <a:latin typeface="Times New Roman" panose="02020603050405020304" pitchFamily="18" charset="0"/>
-              <a:cs typeface="Times New Roman" panose="02020603050405020304" pitchFamily="18" charset="0"/>
-            </a:endParaRPr>
-          </a:p>
-          <a:p>
-            <a:pPr algn="just">
-              <a:lnSpc>
-                <a:spcPct val="200000"/>
-              </a:lnSpc>
-              <a:buNone/>
-            </a:pPr>
-            <a:r>
-              <a:rPr lang="es-PE" dirty="0">
-                <a:effectLst/>
-                <a:latin typeface="Times New Roman" panose="02020603050405020304" pitchFamily="18" charset="0"/>
-                <a:cs typeface="Times New Roman" panose="02020603050405020304" pitchFamily="18" charset="0"/>
-              </a:rPr>
-              <a:t>Node.js </a:t>
-            </a:r>
-            <a:r>
-              <a:rPr lang="es-PE" dirty="0" err="1">
-                <a:effectLst/>
-                <a:latin typeface="Times New Roman" panose="02020603050405020304" pitchFamily="18" charset="0"/>
-                <a:cs typeface="Times New Roman" panose="02020603050405020304" pitchFamily="18" charset="0"/>
-              </a:rPr>
-              <a:t>Foundation</a:t>
-            </a:r>
-            <a:r>
-              <a:rPr lang="es-PE" dirty="0">
-                <a:effectLst/>
-                <a:latin typeface="Times New Roman" panose="02020603050405020304" pitchFamily="18" charset="0"/>
-                <a:cs typeface="Times New Roman" panose="02020603050405020304" pitchFamily="18" charset="0"/>
-              </a:rPr>
-              <a:t>. (2024). </a:t>
-            </a:r>
-            <a:r>
-              <a:rPr lang="es-PE" i="1" dirty="0">
-                <a:effectLst/>
-                <a:latin typeface="Times New Roman" panose="02020603050405020304" pitchFamily="18" charset="0"/>
-                <a:cs typeface="Times New Roman" panose="02020603050405020304" pitchFamily="18" charset="0"/>
-              </a:rPr>
-              <a:t>Documentación oficial de Express.js</a:t>
-            </a:r>
-            <a:r>
-              <a:rPr lang="es-PE" dirty="0">
-                <a:effectLst/>
-                <a:latin typeface="Times New Roman" panose="02020603050405020304" pitchFamily="18" charset="0"/>
-                <a:cs typeface="Times New Roman" panose="02020603050405020304" pitchFamily="18" charset="0"/>
-              </a:rPr>
-              <a:t>. </a:t>
-            </a:r>
-            <a:r>
-              <a:rPr lang="es-PE" dirty="0" err="1">
-                <a:effectLst/>
-                <a:latin typeface="Times New Roman" panose="02020603050405020304" pitchFamily="18" charset="0"/>
-                <a:cs typeface="Times New Roman" panose="02020603050405020304" pitchFamily="18" charset="0"/>
-              </a:rPr>
-              <a:t>OpenJS</a:t>
-            </a:r>
-            <a:r>
-              <a:rPr lang="es-PE" dirty="0">
-                <a:effectLst/>
-                <a:latin typeface="Times New Roman" panose="02020603050405020304" pitchFamily="18" charset="0"/>
-                <a:cs typeface="Times New Roman" panose="02020603050405020304" pitchFamily="18" charset="0"/>
-              </a:rPr>
-              <a:t> </a:t>
-            </a:r>
-            <a:r>
-              <a:rPr lang="es-PE" dirty="0" err="1">
-                <a:effectLst/>
-                <a:latin typeface="Times New Roman" panose="02020603050405020304" pitchFamily="18" charset="0"/>
-                <a:cs typeface="Times New Roman" panose="02020603050405020304" pitchFamily="18" charset="0"/>
-              </a:rPr>
-              <a:t>Foundation</a:t>
-            </a:r>
-            <a:r>
-              <a:rPr lang="es-PE" dirty="0">
-                <a:effectLst/>
-                <a:latin typeface="Times New Roman" panose="02020603050405020304" pitchFamily="18" charset="0"/>
-                <a:cs typeface="Times New Roman" panose="02020603050405020304" pitchFamily="18" charset="0"/>
-              </a:rPr>
-              <a:t>. </a:t>
-            </a:r>
-            <a:r>
-              <a:rPr lang="es-PE" dirty="0">
-                <a:effectLst/>
-                <a:latin typeface="Times New Roman" panose="02020603050405020304" pitchFamily="18" charset="0"/>
-                <a:cs typeface="Times New Roman" panose="02020603050405020304" pitchFamily="18" charset="0"/>
-                <a:hlinkClick r:id="rId4"/>
-              </a:rPr>
-              <a:t>https://expressjs.com/es/</a:t>
-            </a:r>
-            <a:endParaRPr lang="es-PE" dirty="0">
-              <a:effectLst/>
-              <a:latin typeface="Times New Roman" panose="02020603050405020304" pitchFamily="18" charset="0"/>
-              <a:cs typeface="Times New Roman" panose="02020603050405020304" pitchFamily="18" charset="0"/>
-            </a:endParaRPr>
+              <a:t>:</a:t>
+            </a:r>
           </a:p>
         </p:txBody>
       </p:sp>
     </p:spTree>
+    <p:extLst>
+      <p:ext uri="{BB962C8B-B14F-4D97-AF65-F5344CB8AC3E}">
+        <p14:creationId xmlns:p14="http://schemas.microsoft.com/office/powerpoint/2010/main" val="2216830672"/>
+      </p:ext>
+    </p:extLst>
   </p:cSld>
   <p:clrMapOvr>
     <a:masterClrMapping/>

</xml_diff>